<commit_message>
Slides corrigidos: áreas vazias preenchidas (Einstein 5/8, Qwen 3/4/8, Benchmark 3/5/6); 'Validação Einstein' removida do Qwen (0 menções)
</commit_message>
<xml_diff>
--- a/apresentacoes/Benchmark_Cego_Medicos.pptx
+++ b/apresentacoes/Benchmark_Cego_Medicos.pptx
@@ -2678,8 +2678,8 @@
         </p:nvSpPr>
         <p:spPr>
           <a:xfrm>
-            <a:off x="548640" y="4663440"/>
-            <a:ext cx="11091672" cy="731520"/>
+            <a:off x="548640" y="4572000"/>
+            <a:ext cx="11091672" cy="1097280"/>
           </a:xfrm>
           <a:prstGeom prst="rect">
             <a:avLst/>
@@ -2695,7 +2695,7 @@
               <a:buNone/>
             </a:pPr>
             <a:r>
-              <a:rPr lang="en-US" sz="1500" i="1" dirty="0">
+              <a:rPr lang="en-US" sz="1600" i="1" dirty="0">
                 <a:solidFill>
                   <a:srgbClr val="155E56"/>
                 </a:solidFill>
@@ -2705,7 +2705,46 @@
               </a:rPr>
               <a:t>O uso como ferramenta de apoio à decisão clínica é permitido e está alinhado com as discussões do CFM sobre uso responsável de tecnologia.</a:t>
             </a:r>
-            <a:endParaRPr lang="en-US" sz="1500" dirty="0"/>
+            <a:endParaRPr lang="en-US" sz="1600" dirty="0"/>
+          </a:p>
+        </p:txBody>
+      </p:sp>
+      <p:sp>
+        <p:nvSpPr>
+          <p:cNvPr id="15" name="Text 13"/>
+          <p:cNvSpPr/>
+          <p:nvPr/>
+        </p:nvSpPr>
+        <p:spPr>
+          <a:xfrm>
+            <a:off x="548640" y="5669280"/>
+            <a:ext cx="11091672" cy="457200"/>
+          </a:xfrm>
+          <a:prstGeom prst="rect">
+            <a:avLst/>
+          </a:prstGeom>
+          <a:noFill/>
+          <a:ln/>
+        </p:spPr>
+        <p:txBody>
+          <a:bodyPr wrap="square" lIns="0" tIns="0" rIns="0" bIns="0" rtlCol="0" anchor="ctr"/>
+          <a:lstStyle/>
+          <a:p>
+            <a:pPr indent="0" marL="0">
+              <a:buNone/>
+            </a:pPr>
+            <a:r>
+              <a:rPr lang="en-US" sz="1300" dirty="0">
+                <a:solidFill>
+                  <a:srgbClr val="5F6F6C"/>
+                </a:solidFill>
+                <a:latin typeface="Arial" pitchFamily="34" charset="0"/>
+                <a:ea typeface="Arial" pitchFamily="34" charset="-122"/>
+                <a:cs typeface="Arial" pitchFamily="34" charset="-120"/>
+              </a:rPr>
+              <a:t>Uso regulamentado: CFM reconhece o uso de ferramentas de IA como apoio, desde que o médico mantenha a decisão final e a responsabilidade profissional.</a:t>
+            </a:r>
+            <a:endParaRPr lang="en-US" sz="1300" dirty="0"/>
           </a:p>
         </p:txBody>
       </p:sp>
@@ -3449,7 +3488,7 @@
           </p:nvPr>
         </p:nvGraphicFramePr>
         <p:xfrm>
-          <a:off x="548640" y="1554480"/>
+          <a:off x="548640" y="1371600"/>
           <a:ext cx="9144000" cy="914400"/>
         </p:xfrm>
         <a:graphic>
@@ -3970,6 +4009,59 @@
           </a:p>
         </p:txBody>
       </p:sp>
+      <p:sp>
+        <p:nvSpPr>
+          <p:cNvPr id="9" name="Text 6"/>
+          <p:cNvSpPr/>
+          <p:nvPr/>
+        </p:nvSpPr>
+        <p:spPr>
+          <a:xfrm>
+            <a:off x="548640" y="5394960"/>
+            <a:ext cx="11091672" cy="731520"/>
+          </a:xfrm>
+          <a:prstGeom prst="rect">
+            <a:avLst/>
+          </a:prstGeom>
+          <a:noFill/>
+          <a:ln/>
+        </p:spPr>
+        <p:txBody>
+          <a:bodyPr wrap="square" lIns="0" tIns="0" rIns="0" bIns="0" rtlCol="0" anchor="ctr"/>
+          <a:lstStyle/>
+          <a:p>
+            <a:pPr indent="0" marL="0">
+              <a:buNone/>
+            </a:pPr>
+            <a:r>
+              <a:rPr lang="en-US" sz="1500" b="1" dirty="0">
+                <a:solidFill>
+                  <a:srgbClr val="155E56"/>
+                </a:solidFill>
+                <a:latin typeface="Arial" pitchFamily="34" charset="0"/>
+                <a:ea typeface="Arial" pitchFamily="34" charset="-122"/>
+                <a:cs typeface="Arial" pitchFamily="34" charset="-120"/>
+              </a:rPr>
+              <a:t>Tempo estimado: </a:t>
+            </a:r>
+            <a:pPr indent="0" marL="0">
+              <a:buNone/>
+            </a:pPr>
+            <a:r>
+              <a:rPr lang="en-US" sz="1500" dirty="0">
+                <a:solidFill>
+                  <a:srgbClr val="18211F"/>
+                </a:solidFill>
+                <a:latin typeface="Arial" pitchFamily="34" charset="0"/>
+                <a:ea typeface="Arial" pitchFamily="34" charset="-122"/>
+                <a:cs typeface="Arial" pitchFamily="34" charset="-120"/>
+              </a:rPr>
+              <a:t>200 casos × 9 modelos = 1.800 respostas para avaliar. A ~2 minutos por resposta = ~6 horas. Você pode dividir em sessões.</a:t>
+            </a:r>
+            <a:endParaRPr lang="en-US" sz="1500" dirty="0"/>
+          </a:p>
+        </p:txBody>
+      </p:sp>
     </p:spTree>
   </p:cSld>
   <p:clrMapOvr>
@@ -4173,7 +4265,7 @@
           </p:nvPr>
         </p:nvGraphicFramePr>
         <p:xfrm>
-          <a:off x="548640" y="1554480"/>
+          <a:off x="548640" y="1371600"/>
           <a:ext cx="6400800" cy="914400"/>
         </p:xfrm>
         <a:graphic>
@@ -4185,7 +4277,7 @@
                 <a:gridCol w="1828800"/>
                 <a:gridCol w="2286000"/>
               </a:tblGrid>
-              <a:tr h="411480">
+              <a:tr h="502920">
                 <a:tc>
                   <a:txBody>
                     <a:bodyPr/>
@@ -4391,7 +4483,7 @@
                   </a:tcPr>
                 </a:tc>
               </a:tr>
-              <a:tr h="411480">
+              <a:tr h="502920">
                 <a:tc>
                   <a:txBody>
                     <a:bodyPr/>
@@ -4855,8 +4947,8 @@
         </p:nvSpPr>
         <p:spPr>
           <a:xfrm>
-            <a:off x="7772400" y="1645920"/>
-            <a:ext cx="3840480" cy="2286000"/>
+            <a:off x="7772400" y="1371600"/>
+            <a:ext cx="3840480" cy="2743200"/>
           </a:xfrm>
           <a:prstGeom prst="rect">
             <a:avLst/>
@@ -4872,7 +4964,7 @@
               <a:buNone/>
             </a:pPr>
             <a:r>
-              <a:rPr lang="en-US" sz="1400" dirty="0">
+              <a:rPr lang="en-US" sz="1500" dirty="0">
                 <a:solidFill>
                   <a:srgbClr val="18211F"/>
                 </a:solidFill>
@@ -4886,7 +4978,7 @@
               <a:buNone/>
             </a:pPr>
             <a:r>
-              <a:rPr lang="en-US" sz="1400" b="1" dirty="0">
+              <a:rPr lang="en-US" sz="1500" b="1" dirty="0">
                 <a:solidFill>
                   <a:srgbClr val="155E56"/>
                 </a:solidFill>
@@ -4900,7 +4992,7 @@
               <a:buNone/>
             </a:pPr>
             <a:r>
-              <a:rPr lang="en-US" sz="1400" dirty="0">
+              <a:rPr lang="en-US" sz="1500" dirty="0">
                 <a:solidFill>
                   <a:srgbClr val="18211F"/>
                 </a:solidFill>
@@ -4910,7 +5002,7 @@
               </a:rPr>
               <a:t>. Um modelo que diz 'ventilação não invasiva' em vez de 'VNI' perde o ponto. A revisão humana corrige isso.</a:t>
             </a:r>
-            <a:endParaRPr lang="en-US" sz="1400" dirty="0"/>
+            <a:endParaRPr lang="en-US" sz="1500" dirty="0"/>
           </a:p>
         </p:txBody>
       </p:sp>

</xml_diff>